<commit_message>
Refinement Update and Integration
Updated refinement files to more clearly explain the connections among the refinement processes, including the 4 checking steps and the Divine Familial Terms check:
-note about importance of consistency added to QAG Training Guide
-notes about DFTs and their connection to accuracy added to all refinement TGs
-explanation that the different steps of refinement are like different filters to catch different things was added to Refinement Intro, and similar notes added to each refinement module TG.
</commit_message>
<xml_diff>
--- a/training/English (en)/Refinement and Publication Training [R&P]/03 Reviewers' Guide/Reviewers' Guide Training - Slides.pptx
+++ b/training/English (en)/Refinement and Publication Training [R&P]/03 Reviewers' Guide/Reviewers' Guide Training - Slides.pptx
@@ -151,8 +151,8 @@
 <pc:chgInfo xmlns:a="http://schemas.openxmlformats.org/drawingml/2006/main" xmlns:r="http://schemas.openxmlformats.org/officeDocument/2006/relationships" xmlns:ac="http://schemas.microsoft.com/office/drawing/2013/main/command" xmlns:pc="http://schemas.microsoft.com/office/powerpoint/2013/main/command">
   <pc:docChgLst>
     <pc:chgData name="Debbie Shaw" userId="79bf7848-a030-4096-934a-3abbfde4984a" providerId="ADAL" clId="{8DE9E9FB-001C-4B84-83DE-E1F7ABB9FAA3}"/>
-    <pc:docChg chg="modSld">
-      <pc:chgData name="Debbie Shaw" userId="79bf7848-a030-4096-934a-3abbfde4984a" providerId="ADAL" clId="{8DE9E9FB-001C-4B84-83DE-E1F7ABB9FAA3}" dt="2026-07-18T04:57:25.887" v="11" actId="20577"/>
+    <pc:docChg chg="custSel modSld">
+      <pc:chgData name="Debbie Shaw" userId="79bf7848-a030-4096-934a-3abbfde4984a" providerId="ADAL" clId="{8DE9E9FB-001C-4B84-83DE-E1F7ABB9FAA3}" dt="2026-07-31T05:08:42.991" v="25"/>
       <pc:docMkLst>
         <pc:docMk/>
       </pc:docMkLst>
@@ -168,6 +168,21 @@
             <pc:docMk/>
             <pc:sldMk cId="775931000" sldId="299"/>
             <ac:spMk id="2" creationId="{6EF62A67-ABA6-2CE2-ABFF-93FBF4296D64}"/>
+          </ac:spMkLst>
+        </pc:spChg>
+      </pc:sldChg>
+      <pc:sldChg chg="modSp mod addAnim delAnim modAnim">
+        <pc:chgData name="Debbie Shaw" userId="79bf7848-a030-4096-934a-3abbfde4984a" providerId="ADAL" clId="{8DE9E9FB-001C-4B84-83DE-E1F7ABB9FAA3}" dt="2026-07-31T05:08:42.991" v="25"/>
+        <pc:sldMkLst>
+          <pc:docMk/>
+          <pc:sldMk cId="3288827701" sldId="301"/>
+        </pc:sldMkLst>
+        <pc:spChg chg="mod">
+          <ac:chgData name="Debbie Shaw" userId="79bf7848-a030-4096-934a-3abbfde4984a" providerId="ADAL" clId="{8DE9E9FB-001C-4B84-83DE-E1F7ABB9FAA3}" dt="2026-07-31T05:07:42.707" v="24" actId="20577"/>
+          <ac:spMkLst>
+            <pc:docMk/>
+            <pc:sldMk cId="3288827701" sldId="301"/>
+            <ac:spMk id="2" creationId="{12F9E8E5-4198-7221-CA3D-F8AD7BC49620}"/>
           </ac:spMkLst>
         </pc:spChg>
       </pc:sldChg>
@@ -258,7 +273,7 @@
           <a:p>
             <a:fld id="{AC6AA070-92F4-A447-BB88-F5E94FF9CF8B}" type="datetimeFigureOut">
               <a:rPr lang="en-US" smtClean="0"/>
-              <a:t>7/18/2026</a:t>
+              <a:t>7/31/2026</a:t>
             </a:fld>
             <a:endParaRPr lang="en-US"/>
           </a:p>
@@ -662,7 +677,7 @@
           <a:p>
             <a:fld id="{2D176C0A-5C67-429D-B78E-C0F7FE360763}" type="datetimeFigureOut">
               <a:rPr lang="en-US" smtClean="0"/>
-              <a:t>7/18/2026</a:t>
+              <a:t>7/31/2026</a:t>
             </a:fld>
             <a:endParaRPr lang="en-US"/>
           </a:p>
@@ -7628,8 +7643,8 @@
         </p:nvSpPr>
         <p:spPr>
           <a:xfrm>
-            <a:off x="95435" y="487025"/>
-            <a:ext cx="8953130" cy="5878532"/>
+            <a:off x="95435" y="267217"/>
+            <a:ext cx="8953130" cy="6370975"/>
           </a:xfrm>
           <a:prstGeom prst="rect">
             <a:avLst/>
@@ -7645,25 +7660,25 @@
           <a:lstStyle/>
           <a:p>
             <a:r>
-              <a:rPr lang="en-US" sz="2400" b="1"/>
+              <a:rPr lang="en-US" sz="2400" b="1" dirty="0"/>
               <a:t>Part 2</a:t>
             </a:r>
           </a:p>
           <a:p>
             <a:r>
-              <a:rPr lang="en-US" sz="1600"/>
+              <a:rPr lang="en-US" sz="1600" dirty="0"/>
               <a:t>Answer the following questions from the specified verses:</a:t>
             </a:r>
           </a:p>
           <a:p>
-            <a:endParaRPr lang="en-US" sz="1600"/>
+            <a:endParaRPr lang="en-US" sz="1600" dirty="0"/>
           </a:p>
           <a:p>
             <a:pPr marL="342900" indent="-342900">
               <a:buAutoNum type="arabicPeriod"/>
             </a:pPr>
             <a:r>
-              <a:rPr lang="en-US" sz="1600"/>
+              <a:rPr lang="en-US" sz="1600" dirty="0"/>
               <a:t>[3:14] When Jesus came to be baptized, what did John tell Jesus?</a:t>
             </a:r>
           </a:p>
@@ -7671,23 +7686,23 @@
             <a:pPr marL="342900" indent="-342900">
               <a:buAutoNum type="arabicPeriod"/>
             </a:pPr>
-            <a:endParaRPr lang="en-US" sz="1600"/>
+            <a:endParaRPr lang="en-US" sz="1600" dirty="0"/>
           </a:p>
           <a:p>
             <a:r>
-              <a:rPr lang="en-US" sz="1600"/>
+              <a:rPr lang="en-US" sz="1600" dirty="0"/>
               <a:t>	John told Jesus that he needed to be baptized by Jesus.</a:t>
             </a:r>
           </a:p>
           <a:p>
-            <a:endParaRPr lang="en-US" sz="1600"/>
+            <a:endParaRPr lang="en-US" sz="1600" dirty="0"/>
           </a:p>
           <a:p>
             <a:pPr marL="342900" indent="-342900">
               <a:buAutoNum type="arabicPeriod" startAt="2"/>
             </a:pPr>
             <a:r>
-              <a:rPr lang="en-US" sz="1600"/>
+              <a:rPr lang="en-US" sz="1600" dirty="0"/>
               <a:t>[3:15] What did Jesus say was the reason that John should baptize him?</a:t>
             </a:r>
           </a:p>
@@ -7695,23 +7710,23 @@
             <a:pPr marL="342900" indent="-342900">
               <a:buAutoNum type="arabicPeriod" startAt="2"/>
             </a:pPr>
-            <a:endParaRPr lang="en-US" sz="1600"/>
+            <a:endParaRPr lang="en-US" sz="1600" dirty="0"/>
           </a:p>
           <a:p>
             <a:r>
-              <a:rPr lang="en-US" sz="1600"/>
+              <a:rPr lang="en-US" sz="1600" dirty="0"/>
               <a:t>	It was right for them to fulfill all righteousness.</a:t>
             </a:r>
           </a:p>
           <a:p>
-            <a:endParaRPr lang="en-US" sz="1600"/>
+            <a:endParaRPr lang="en-US" sz="1600" dirty="0"/>
           </a:p>
           <a:p>
             <a:pPr marL="342900" indent="-342900">
               <a:buAutoNum type="arabicPeriod" startAt="3"/>
             </a:pPr>
             <a:r>
-              <a:rPr lang="en-US" sz="1600"/>
+              <a:rPr lang="en-US" sz="1600" dirty="0"/>
               <a:t>[3:16] What did the Spirit of God do when Jesus came out of the water?</a:t>
             </a:r>
           </a:p>
@@ -7719,23 +7734,23 @@
             <a:pPr marL="342900" indent="-342900">
               <a:buAutoNum type="arabicPeriod" startAt="3"/>
             </a:pPr>
-            <a:endParaRPr lang="en-US" sz="1600"/>
+            <a:endParaRPr lang="en-US" sz="1600" dirty="0"/>
           </a:p>
           <a:p>
             <a:r>
-              <a:rPr lang="en-US" sz="1600"/>
+              <a:rPr lang="en-US" sz="1600" dirty="0"/>
               <a:t>	The Spirit of God came down and rested on Jesus.</a:t>
             </a:r>
           </a:p>
           <a:p>
-            <a:endParaRPr lang="en-US" sz="1600"/>
+            <a:endParaRPr lang="en-US" sz="1600" dirty="0"/>
           </a:p>
           <a:p>
             <a:pPr marL="342900" indent="-342900">
               <a:buAutoNum type="arabicPeriod" startAt="4"/>
             </a:pPr>
             <a:r>
-              <a:rPr lang="en-US" sz="1600"/>
+              <a:rPr lang="en-US" sz="1600" dirty="0"/>
               <a:t>[3:17] What did the voice from heaven say after Jesus came out of the water?</a:t>
             </a:r>
           </a:p>
@@ -7743,40 +7758,53 @@
             <a:pPr marL="342900" indent="-342900">
               <a:buAutoNum type="arabicPeriod" startAt="4"/>
             </a:pPr>
-            <a:endParaRPr lang="en-US" sz="1600"/>
+            <a:endParaRPr lang="en-US" sz="1600" dirty="0"/>
           </a:p>
           <a:p>
             <a:r>
-              <a:rPr lang="en-US" sz="1600"/>
+              <a:rPr lang="en-US" sz="1600" dirty="0"/>
               <a:t>	The voice said, “This is my beloved Son. I am very pleased with him.”</a:t>
             </a:r>
           </a:p>
           <a:p>
-            <a:endParaRPr lang="en-US" sz="1600"/>
+            <a:endParaRPr lang="en-US" sz="1600" dirty="0"/>
           </a:p>
           <a:p>
             <a:pPr marL="342900" indent="-342900">
               <a:buAutoNum type="arabicPeriod" startAt="5"/>
             </a:pPr>
             <a:r>
-              <a:rPr lang="en-US" sz="1600"/>
+              <a:rPr lang="en-US" sz="1600" dirty="0"/>
               <a:t>[3:17] Whose voice do you think was speaking?</a:t>
             </a:r>
           </a:p>
           <a:p>
-            <a:endParaRPr lang="en-US" sz="1600"/>
+            <a:endParaRPr lang="en-US" sz="1600" dirty="0"/>
           </a:p>
           <a:p>
             <a:r>
-              <a:rPr lang="en-US" sz="1600"/>
+              <a:rPr lang="en-US" sz="1600" dirty="0"/>
               <a:t>	By saying the voice came out of heaven, the passage shows that it was the voice of </a:t>
             </a:r>
             <a:br>
-              <a:rPr lang="en-US" sz="1600"/>
+              <a:rPr lang="en-US" sz="1600" dirty="0"/>
             </a:br>
             <a:r>
+              <a:rPr lang="en-US" sz="1600" dirty="0"/>
+              <a:t>	God the </a:t>
+            </a:r>
+            <a:r>
               <a:rPr lang="en-US" sz="1600"/>
-              <a:t>	God the Father.</a:t>
+              <a:t>Father.</a:t>
+            </a:r>
+          </a:p>
+          <a:p>
+            <a:endParaRPr lang="en-US" sz="1600" dirty="0"/>
+          </a:p>
+          <a:p>
+            <a:r>
+              <a:rPr lang="en-US" sz="1600" b="1" dirty="0"/>
+              <a:t>Comments:</a:t>
             </a:r>
           </a:p>
         </p:txBody>
@@ -8334,6 +8362,46 @@
                                           <p:spTgt spid="2">
                                             <p:txEl>
                                               <p:pRg st="21" end="21"/>
+                                            </p:txEl>
+                                          </p:spTgt>
+                                        </p:tgtEl>
+                                        <p:attrNameLst>
+                                          <p:attrName>style.visibility</p:attrName>
+                                        </p:attrNameLst>
+                                      </p:cBhvr>
+                                      <p:to>
+                                        <p:strVal val="visible"/>
+                                      </p:to>
+                                    </p:set>
+                                  </p:childTnLst>
+                                </p:cTn>
+                              </p:par>
+                            </p:childTnLst>
+                          </p:cTn>
+                        </p:par>
+                        <p:par>
+                          <p:cTn id="47" fill="hold">
+                            <p:stCondLst>
+                              <p:cond delay="0"/>
+                            </p:stCondLst>
+                            <p:childTnLst>
+                              <p:par>
+                                <p:cTn id="48" presetID="1" presetClass="entr" presetSubtype="0" fill="hold" nodeType="afterEffect">
+                                  <p:stCondLst>
+                                    <p:cond delay="0"/>
+                                  </p:stCondLst>
+                                  <p:childTnLst>
+                                    <p:set>
+                                      <p:cBhvr>
+                                        <p:cTn id="49" dur="1" fill="hold">
+                                          <p:stCondLst>
+                                            <p:cond delay="0"/>
+                                          </p:stCondLst>
+                                        </p:cTn>
+                                        <p:tgtEl>
+                                          <p:spTgt spid="2">
+                                            <p:txEl>
+                                              <p:pRg st="23" end="23"/>
                                             </p:txEl>
                                           </p:spTgt>
                                         </p:tgtEl>
@@ -12649,12 +12717,6 @@
 </file>
 
 <file path=customXml/item1.xml><?xml version="1.0" encoding="utf-8"?>
-<p:properties xmlns:p="http://schemas.microsoft.com/office/2006/metadata/properties" xmlns:xsi="http://www.w3.org/2001/XMLSchema-instance" xmlns:pc="http://schemas.microsoft.com/office/infopath/2007/PartnerControls">
-  <documentManagement/>
-</p:properties>
-</file>
-
-<file path=customXml/item2.xml><?xml version="1.0" encoding="utf-8"?>
 <?mso-contentType ?>
 <FormTemplates xmlns="http://schemas.microsoft.com/sharepoint/v3/contenttype/forms">
   <Display>DocumentLibraryForm</Display>
@@ -12663,7 +12725,7 @@
 </FormTemplates>
 </file>
 
-<file path=customXml/item3.xml><?xml version="1.0" encoding="utf-8"?>
+<file path=customXml/item2.xml><?xml version="1.0" encoding="utf-8"?>
 <ct:contentTypeSchema xmlns:ct="http://schemas.microsoft.com/office/2006/metadata/contentType" xmlns:ma="http://schemas.microsoft.com/office/2006/metadata/properties/metaAttributes" ct:_="" ma:_="" ma:contentTypeName="Document" ma:contentTypeID="0x0101002F017C5ECD5AE84588140775F5D9B6FC" ma:contentTypeVersion="10" ma:contentTypeDescription="Create a new document." ma:contentTypeScope="" ma:versionID="1a5380cb2be4a51461126b02f947e923">
   <xsd:schema xmlns:xsd="http://www.w3.org/2001/XMLSchema" xmlns:xs="http://www.w3.org/2001/XMLSchema" xmlns:p="http://schemas.microsoft.com/office/2006/metadata/properties" xmlns:ns2="fee82e44-1fa4-4144-8309-00fed2bf4198" xmlns:ns3="1a61c928-f5f6-4989-bd5d-cb8872a1b06d" targetNamespace="http://schemas.microsoft.com/office/2006/metadata/properties" ma:root="true" ma:fieldsID="9bf58d68fa2085cb5739c341b0c4cacb" ns2:_="" ns3:_="">
     <xsd:import namespace="fee82e44-1fa4-4144-8309-00fed2bf4198"/>
@@ -12864,24 +12926,13 @@
 </ct:contentTypeSchema>
 </file>
 
-<file path=customXml/itemProps1.xml><?xml version="1.0" encoding="utf-8"?>
-<ds:datastoreItem xmlns:ds="http://schemas.openxmlformats.org/officeDocument/2006/customXml" ds:itemID="{DD870300-B03F-45F7-9154-521D8C74684E}">
-  <ds:schemaRefs>
-    <ds:schemaRef ds:uri="http://purl.org/dc/elements/1.1/"/>
-    <ds:schemaRef ds:uri="1a61c928-f5f6-4989-bd5d-cb8872a1b06d"/>
-    <ds:schemaRef ds:uri="http://schemas.microsoft.com/office/infopath/2007/PartnerControls"/>
-    <ds:schemaRef ds:uri="http://schemas.openxmlformats.org/package/2006/metadata/core-properties"/>
-    <ds:schemaRef ds:uri="fee82e44-1fa4-4144-8309-00fed2bf4198"/>
-    <ds:schemaRef ds:uri="http://schemas.microsoft.com/office/2006/metadata/properties"/>
-    <ds:schemaRef ds:uri="http://schemas.microsoft.com/office/2006/documentManagement/types"/>
-    <ds:schemaRef ds:uri="http://www.w3.org/XML/1998/namespace"/>
-    <ds:schemaRef ds:uri="http://purl.org/dc/dcmitype/"/>
-    <ds:schemaRef ds:uri="http://purl.org/dc/terms/"/>
-  </ds:schemaRefs>
-</ds:datastoreItem>
+<file path=customXml/item3.xml><?xml version="1.0" encoding="utf-8"?>
+<p:properties xmlns:p="http://schemas.microsoft.com/office/2006/metadata/properties" xmlns:xsi="http://www.w3.org/2001/XMLSchema-instance" xmlns:pc="http://schemas.microsoft.com/office/infopath/2007/PartnerControls">
+  <documentManagement/>
+</p:properties>
 </file>
 
-<file path=customXml/itemProps2.xml><?xml version="1.0" encoding="utf-8"?>
+<file path=customXml/itemProps1.xml><?xml version="1.0" encoding="utf-8"?>
 <ds:datastoreItem xmlns:ds="http://schemas.openxmlformats.org/officeDocument/2006/customXml" ds:itemID="{B178770A-F6AC-406B-AF0D-88CBCF36B701}">
   <ds:schemaRefs>
     <ds:schemaRef ds:uri="http://schemas.microsoft.com/sharepoint/v3/contenttype/forms"/>
@@ -12889,7 +12940,7 @@
 </ds:datastoreItem>
 </file>
 
-<file path=customXml/itemProps3.xml><?xml version="1.0" encoding="utf-8"?>
+<file path=customXml/itemProps2.xml><?xml version="1.0" encoding="utf-8"?>
 <ds:datastoreItem xmlns:ds="http://schemas.openxmlformats.org/officeDocument/2006/customXml" ds:itemID="{48B975BD-FF54-421D-AEC7-A8AE09732533}">
   <ds:schemaRefs>
     <ds:schemaRef ds:uri="1a61c928-f5f6-4989-bd5d-cb8872a1b06d"/>
@@ -12906,4 +12957,21 @@
     <ds:schemaRef ds:uri="http://www.w3.org/2001/XMLSchema"/>
   </ds:schemaRefs>
 </ds:datastoreItem>
+</file>
+
+<file path=customXml/itemProps3.xml><?xml version="1.0" encoding="utf-8"?>
+<ds:datastoreItem xmlns:ds="http://schemas.openxmlformats.org/officeDocument/2006/customXml" ds:itemID="{DD870300-B03F-45F7-9154-521D8C74684E}">
+  <ds:schemaRefs>
+    <ds:schemaRef ds:uri="http://purl.org/dc/elements/1.1/"/>
+    <ds:schemaRef ds:uri="1a61c928-f5f6-4989-bd5d-cb8872a1b06d"/>
+    <ds:schemaRef ds:uri="http://schemas.microsoft.com/office/infopath/2007/PartnerControls"/>
+    <ds:schemaRef ds:uri="http://schemas.openxmlformats.org/package/2006/metadata/core-properties"/>
+    <ds:schemaRef ds:uri="fee82e44-1fa4-4144-8309-00fed2bf4198"/>
+    <ds:schemaRef ds:uri="http://schemas.microsoft.com/office/2006/metadata/properties"/>
+    <ds:schemaRef ds:uri="http://schemas.microsoft.com/office/2006/documentManagement/types"/>
+    <ds:schemaRef ds:uri="http://www.w3.org/XML/1998/namespace"/>
+    <ds:schemaRef ds:uri="http://purl.org/dc/dcmitype/"/>
+    <ds:schemaRef ds:uri="http://purl.org/dc/terms/"/>
+  </ds:schemaRefs>
+</ds:datastoreItem>
 </file>
</xml_diff>